<commit_message>
test(eval): refresh deck fixture with required slide layout
</commit_message>
<xml_diff>
--- a/internal/eval/testdata/user-work-v4/sources/deck-update/monthly-review.pptx
+++ b/internal/eval/testdata/user-work-v4/sources/deck-update/monthly-review.pptx
@@ -1,14 +1,17 @@
 
 <file path=ppt/presentation.xml><?xml version="1.0" encoding="utf-8"?>
 <p:presentation xmlns:a="http://schemas.openxmlformats.org/drawingml/2006/main" xmlns:r="http://schemas.openxmlformats.org/officeDocument/2006/relationships" xmlns:p="http://schemas.openxmlformats.org/presentationml/2006/main">
+  <p:sldMasterIdLst>
+    <p:sldMasterId id="2147483648" r:id="rId6"/>
+  </p:sldMasterIdLst>
+  <p:notesMasterIdLst>
+    <p:notesMasterId r:id="rId4"/>
+  </p:notesMasterIdLst>
   <p:sldIdLst>
     <p:sldId id="256" r:id="rId1"/>
     <p:sldId id="257" r:id="rId2"/>
     <p:sldId id="258" r:id="rId3"/>
   </p:sldIdLst>
-  <p:notesMasterIdLst>
-    <p:notesMasterId r:id="rId4"/>
-  </p:notesMasterIdLst>
   <p:sldSz cx="12192000" cy="6858000" type="screen16x9"/>
   <p:notesSz cx="6858000" cy="9144000"/>
 </p:presentation>
@@ -28,8 +31,58 @@
   </p:cSld>
   <p:clrMap bg1="lt1" tx1="dk1" bg2="lt2" tx2="dk2" accent1="accent1" accent2="accent2" accent3="accent3" accent4="accent4" accent5="accent5" accent6="accent6" hlink="hlink" folHlink="folHlink"/>
   <p:hf dt="0" hdr="0" ftr="0" sldNum="0"/>
-  <p:txStyles/>
+  <p:notesStyle/>
 </p:notesMaster>
+</file>
+
+<file path=ppt/slideLayouts/slideLayout1.xml><?xml version="1.0" encoding="utf-8"?>
+<p:sldLayout xmlns:a="http://schemas.openxmlformats.org/drawingml/2006/main" xmlns:r="http://schemas.openxmlformats.org/officeDocument/2006/relationships" xmlns:p="http://schemas.openxmlformats.org/presentationml/2006/main" type="blank" preserve="1">
+  <p:cSld name="Blank">
+    <p:spTree>
+      <p:nvGrpSpPr>
+        <p:cNvPr id="1" name=""/>
+        <p:cNvGrpSpPr/>
+        <p:nvPr/>
+      </p:nvGrpSpPr>
+      <p:grpSpPr/>
+    </p:spTree>
+  </p:cSld>
+  <p:clrMapOvr>
+    <a:masterClrMapping/>
+  </p:clrMapOvr>
+</p:sldLayout>
+</file>
+
+<file path=ppt/slideMasters/slideMaster1.xml><?xml version="1.0" encoding="utf-8"?>
+<p:sldMaster xmlns:a="http://schemas.openxmlformats.org/drawingml/2006/main" xmlns:r="http://schemas.openxmlformats.org/officeDocument/2006/relationships" xmlns:p="http://schemas.openxmlformats.org/presentationml/2006/main">
+  <p:cSld>
+    <p:bg>
+      <p:bgPr>
+        <a:solidFill>
+          <a:srgbClr val="FFFFFF"/>
+        </a:solidFill>
+        <a:effectLst/>
+      </p:bgPr>
+    </p:bg>
+    <p:spTree>
+      <p:nvGrpSpPr>
+        <p:cNvPr id="1" name=""/>
+        <p:cNvGrpSpPr/>
+        <p:nvPr/>
+      </p:nvGrpSpPr>
+      <p:grpSpPr/>
+    </p:spTree>
+  </p:cSld>
+  <p:clrMap bg1="lt1" tx1="dk1" bg2="lt2" tx2="dk2" accent1="accent1" accent2="accent2" accent3="accent3" accent4="accent4" accent5="accent5" accent6="accent6" hlink="hlink" folHlink="folHlink"/>
+  <p:sldLayoutIdLst>
+    <p:sldLayoutId id="2147483649" r:id="rId1"/>
+  </p:sldLayoutIdLst>
+  <p:txStyles>
+    <p:titleStyle/>
+    <p:bodyStyle/>
+    <p:otherStyle/>
+  </p:txStyles>
+</p:sldMaster>
 </file>
 
 <file path=ppt/slides/slide1.xml><?xml version="1.0" encoding="utf-8"?>
@@ -105,8 +158,17 @@
                   <a:srgbClr val="275D8C"/>
                 </a:solidFill>
               </a:rPr>
-              <a:t>September 2026 draft
-Prepared for operations leadership</a:t>
+              <a:t>September 2026 draft</a:t>
+            </a:r>
+          </a:p>
+          <a:p>
+            <a:r>
+              <a:rPr lang="en-US" sz="1800">
+                <a:solidFill>
+                  <a:srgbClr val="275D8C"/>
+                </a:solidFill>
+              </a:rPr>
+              <a:t>Prepared for operations leadership</a:t>
             </a:r>
           </a:p>
         </p:txBody>
@@ -192,8 +254,17 @@
                   <a:srgbClr val="275D8C"/>
                 </a:solidFill>
               </a:rPr>
-              <a:t>Availability: 99.2%
-Open priority-one tickets: 2</a:t>
+              <a:t>Availability: 99.2%</a:t>
+            </a:r>
+          </a:p>
+          <a:p>
+            <a:r>
+              <a:rPr lang="en-US" sz="1800">
+                <a:solidFill>
+                  <a:srgbClr val="275D8C"/>
+                </a:solidFill>
+              </a:rPr>
+              <a:t>Open priority-one tickets: 2</a:t>
             </a:r>
           </a:p>
         </p:txBody>
@@ -336,16 +407,69 @@
     <a:fontScheme name="Gator">
       <a:majorFont>
         <a:latin typeface="Aptos Display"/>
+        <a:ea typeface=""/>
+        <a:cs typeface=""/>
       </a:majorFont>
       <a:minorFont>
         <a:latin typeface="Aptos"/>
+        <a:ea typeface=""/>
+        <a:cs typeface=""/>
       </a:minorFont>
     </a:fontScheme>
     <a:fmtScheme name="Gator">
-      <a:fillStyleLst/>
-      <a:lnStyleLst/>
-      <a:effectStyleLst/>
-      <a:bgFillStyleLst/>
+      <a:fillStyleLst>
+        <a:solidFill>
+          <a:schemeClr val="phClr"/>
+        </a:solidFill>
+        <a:solidFill>
+          <a:schemeClr val="phClr"/>
+        </a:solidFill>
+        <a:solidFill>
+          <a:schemeClr val="phClr"/>
+        </a:solidFill>
+      </a:fillStyleLst>
+      <a:lnStyleLst>
+        <a:ln w="9525" cap="flat" cmpd="sng" algn="ctr">
+          <a:solidFill>
+            <a:schemeClr val="phClr"/>
+          </a:solidFill>
+          <a:prstDash val="solid"/>
+        </a:ln>
+        <a:ln w="9525" cap="flat" cmpd="sng" algn="ctr">
+          <a:solidFill>
+            <a:schemeClr val="phClr"/>
+          </a:solidFill>
+          <a:prstDash val="solid"/>
+        </a:ln>
+        <a:ln w="9525" cap="flat" cmpd="sng" algn="ctr">
+          <a:solidFill>
+            <a:schemeClr val="phClr"/>
+          </a:solidFill>
+          <a:prstDash val="solid"/>
+        </a:ln>
+      </a:lnStyleLst>
+      <a:effectStyleLst>
+        <a:effectStyle>
+          <a:effectLst/>
+        </a:effectStyle>
+        <a:effectStyle>
+          <a:effectLst/>
+        </a:effectStyle>
+        <a:effectStyle>
+          <a:effectLst/>
+        </a:effectStyle>
+      </a:effectStyleLst>
+      <a:bgFillStyleLst>
+        <a:solidFill>
+          <a:schemeClr val="phClr"/>
+        </a:solidFill>
+        <a:solidFill>
+          <a:schemeClr val="phClr"/>
+        </a:solidFill>
+        <a:solidFill>
+          <a:schemeClr val="phClr"/>
+        </a:solidFill>
+      </a:bgFillStyleLst>
     </a:fmtScheme>
   </a:themeElements>
 </a:theme>

</xml_diff>